<commit_message>
Add the narrated demo video, its script and the live links
submission/axiom_demo.mp4 is the 2:44 walkthrough of the web app with the
ElevenLabs voiceover from submission/voiceover.txt; demo_script.md has the
timed shot list. README and deck now point at the video and at the live
Vercel and Render deployments.
</commit_message>
<xml_diff>
--- a/submission/Thapar_Incognito_Submission.pptx
+++ b/submission/Thapar_Incognito_Submission.pptx
@@ -14905,7 +14905,7 @@
             <a:avLst/>
           </a:prstGeom>
           <a:solidFill>
-            <a:srgbClr val="63637E"/>
+            <a:srgbClr val="6D28D9"/>
           </a:solidFill>
           <a:ln>
             <a:noFill/>
@@ -14923,7 +14923,7 @@
                 </a:solidFill>
                 <a:latin typeface="Calibri"/>
               </a:rPr>
-              <a:t>…</a:t>
+              <a:t>Y</a:t>
             </a:r>
           </a:p>
         </p:txBody>
@@ -14989,11 +14989,11 @@
             <a:r>
               <a:rPr sz="1300" b="0" i="0">
                 <a:solidFill>
-                  <a:srgbClr val="6D28D9"/>
-                </a:solidFill>
-                <a:latin typeface="Calibri"/>
-              </a:rPr>
-              <a:t>LINK TO BE ADDED</a:t>
+                  <a:srgbClr val="63637E"/>
+                </a:solidFill>
+                <a:latin typeface="Calibri"/>
+              </a:rPr>
+              <a:t>submission/axiom_demo.mp4 in the repository</a:t>
             </a:r>
           </a:p>
         </p:txBody>
@@ -18952,7 +18952,7 @@
                 </a:solidFill>
                 <a:latin typeface="Calibri"/>
               </a:rPr>
-              <a:t>Demo video (≤ 5 min): LINK TO BE ADDED</a:t>
+              <a:t>Demo video: submission/axiom_demo.mp4 · Live: axiom-nine-delta.vercel.app</a:t>
             </a:r>
           </a:p>
         </p:txBody>

</xml_diff>

<commit_message>
Add all four member emails to the title slide
</commit_message>
<xml_diff>
--- a/submission/Thapar_Incognito_Submission.pptx
+++ b/submission/Thapar_Incognito_Submission.pptx
@@ -13336,7 +13336,7 @@
                 <a:cs typeface="Calibri"/>
                 <a:sym typeface="Calibri"/>
               </a:rPr>
-              <a:t>Prabinder Singh</a:t>
+              <a:t>Prabinder Singh · psingh16_be24@thapar.edu</a:t>
             </a:r>
             <a:endParaRPr/>
           </a:p>
@@ -13380,7 +13380,7 @@
                 <a:cs typeface="Calibri"/>
                 <a:sym typeface="Calibri"/>
               </a:rPr>
-              <a:t>Anish Grover</a:t>
+              <a:t>Anish Grover · agrover_be24@thapar.edu</a:t>
             </a:r>
             <a:endParaRPr/>
           </a:p>
@@ -13468,7 +13468,7 @@
                 <a:cs typeface="Calibri"/>
                 <a:sym typeface="Calibri"/>
               </a:rPr>
-              <a:t>Parth Deshmukh</a:t>
+              <a:t>Parth Deshmukh · pdeshmukh_be24@thapar.edu</a:t>
             </a:r>
             <a:endParaRPr/>
           </a:p>

</xml_diff>

<commit_message>
Link the demo video on YouTube
</commit_message>
<xml_diff>
--- a/submission/Thapar_Incognito_Submission.pptx
+++ b/submission/Thapar_Incognito_Submission.pptx
@@ -14993,7 +14993,7 @@
                 </a:solidFill>
                 <a:latin typeface="Calibri"/>
               </a:rPr>
-              <a:t>submission/axiom_demo.mp4 in the repository</a:t>
+              <a:t>youtu.be/QSGzV12PyO4</a:t>
             </a:r>
           </a:p>
         </p:txBody>
@@ -18952,7 +18952,7 @@
                 </a:solidFill>
                 <a:latin typeface="Calibri"/>
               </a:rPr>
-              <a:t>Demo video: submission/axiom_demo.mp4 · Live: axiom-nine-delta.vercel.app</a:t>
+              <a:t>Demo video: youtu.be/QSGzV12PyO4 · Live: axiom-nine-delta.vercel.app</a:t>
             </a:r>
           </a:p>
         </p:txBody>

</xml_diff>